<commit_message>
Update Key and slides.
</commit_message>
<xml_diff>
--- a/Presentation/Recipes_from_Pictures.pptx
+++ b/Presentation/Recipes_from_Pictures.pptx
@@ -295,7 +295,8 @@
           <a:p>
             <a:fld id="{427B8E36-3EEC-47D8-B8BA-CB974FD2B1EA}" type="datetimeFigureOut">
               <a:rPr lang="en-US" smtClean="0"/>
-              <a:t>4/11/2026</a:t>
+              <a:pPr/>
+              <a:t>4/12/2026</a:t>
             </a:fld>
             <a:endParaRPr lang="en-US"/>
           </a:p>
@@ -337,6 +338,7 @@
           <a:p>
             <a:fld id="{616C4FD7-C31A-4C8B-B854-0E3DE6100231}" type="slidenum">
               <a:rPr lang="en-US" smtClean="0"/>
+              <a:pPr/>
               <a:t>‹#›</a:t>
             </a:fld>
             <a:endParaRPr lang="en-US"/>
@@ -460,7 +462,8 @@
           <a:p>
             <a:fld id="{427B8E36-3EEC-47D8-B8BA-CB974FD2B1EA}" type="datetimeFigureOut">
               <a:rPr lang="en-US" smtClean="0"/>
-              <a:t>4/11/2026</a:t>
+              <a:pPr/>
+              <a:t>4/12/2026</a:t>
             </a:fld>
             <a:endParaRPr lang="en-US"/>
           </a:p>
@@ -502,6 +505,7 @@
           <a:p>
             <a:fld id="{616C4FD7-C31A-4C8B-B854-0E3DE6100231}" type="slidenum">
               <a:rPr lang="en-US" smtClean="0"/>
+              <a:pPr/>
               <a:t>‹#›</a:t>
             </a:fld>
             <a:endParaRPr lang="en-US"/>
@@ -635,7 +639,8 @@
           <a:p>
             <a:fld id="{427B8E36-3EEC-47D8-B8BA-CB974FD2B1EA}" type="datetimeFigureOut">
               <a:rPr lang="en-US" smtClean="0"/>
-              <a:t>4/11/2026</a:t>
+              <a:pPr/>
+              <a:t>4/12/2026</a:t>
             </a:fld>
             <a:endParaRPr lang="en-US"/>
           </a:p>
@@ -677,6 +682,7 @@
           <a:p>
             <a:fld id="{616C4FD7-C31A-4C8B-B854-0E3DE6100231}" type="slidenum">
               <a:rPr lang="en-US" smtClean="0"/>
+              <a:pPr/>
               <a:t>‹#›</a:t>
             </a:fld>
             <a:endParaRPr lang="en-US"/>
@@ -800,7 +806,8 @@
           <a:p>
             <a:fld id="{427B8E36-3EEC-47D8-B8BA-CB974FD2B1EA}" type="datetimeFigureOut">
               <a:rPr lang="en-US" smtClean="0"/>
-              <a:t>4/11/2026</a:t>
+              <a:pPr/>
+              <a:t>4/12/2026</a:t>
             </a:fld>
             <a:endParaRPr lang="en-US"/>
           </a:p>
@@ -842,6 +849,7 @@
           <a:p>
             <a:fld id="{616C4FD7-C31A-4C8B-B854-0E3DE6100231}" type="slidenum">
               <a:rPr lang="en-US" smtClean="0"/>
+              <a:pPr/>
               <a:t>‹#›</a:t>
             </a:fld>
             <a:endParaRPr lang="en-US"/>
@@ -1041,7 +1049,8 @@
           <a:p>
             <a:fld id="{427B8E36-3EEC-47D8-B8BA-CB974FD2B1EA}" type="datetimeFigureOut">
               <a:rPr lang="en-US" smtClean="0"/>
-              <a:t>4/11/2026</a:t>
+              <a:pPr/>
+              <a:t>4/12/2026</a:t>
             </a:fld>
             <a:endParaRPr lang="en-US"/>
           </a:p>
@@ -1083,6 +1092,7 @@
           <a:p>
             <a:fld id="{616C4FD7-C31A-4C8B-B854-0E3DE6100231}" type="slidenum">
               <a:rPr lang="en-US" smtClean="0"/>
+              <a:pPr/>
               <a:t>‹#›</a:t>
             </a:fld>
             <a:endParaRPr lang="en-US"/>
@@ -1324,7 +1334,8 @@
           <a:p>
             <a:fld id="{427B8E36-3EEC-47D8-B8BA-CB974FD2B1EA}" type="datetimeFigureOut">
               <a:rPr lang="en-US" smtClean="0"/>
-              <a:t>4/11/2026</a:t>
+              <a:pPr/>
+              <a:t>4/12/2026</a:t>
             </a:fld>
             <a:endParaRPr lang="en-US"/>
           </a:p>
@@ -1366,6 +1377,7 @@
           <a:p>
             <a:fld id="{616C4FD7-C31A-4C8B-B854-0E3DE6100231}" type="slidenum">
               <a:rPr lang="en-US" smtClean="0"/>
+              <a:pPr/>
               <a:t>‹#›</a:t>
             </a:fld>
             <a:endParaRPr lang="en-US"/>
@@ -1741,7 +1753,8 @@
           <a:p>
             <a:fld id="{427B8E36-3EEC-47D8-B8BA-CB974FD2B1EA}" type="datetimeFigureOut">
               <a:rPr lang="en-US" smtClean="0"/>
-              <a:t>4/11/2026</a:t>
+              <a:pPr/>
+              <a:t>4/12/2026</a:t>
             </a:fld>
             <a:endParaRPr lang="en-US"/>
           </a:p>
@@ -1783,6 +1796,7 @@
           <a:p>
             <a:fld id="{616C4FD7-C31A-4C8B-B854-0E3DE6100231}" type="slidenum">
               <a:rPr lang="en-US" smtClean="0"/>
+              <a:pPr/>
               <a:t>‹#›</a:t>
             </a:fld>
             <a:endParaRPr lang="en-US"/>
@@ -1854,7 +1868,8 @@
           <a:p>
             <a:fld id="{427B8E36-3EEC-47D8-B8BA-CB974FD2B1EA}" type="datetimeFigureOut">
               <a:rPr lang="en-US" smtClean="0"/>
-              <a:t>4/11/2026</a:t>
+              <a:pPr/>
+              <a:t>4/12/2026</a:t>
             </a:fld>
             <a:endParaRPr lang="en-US"/>
           </a:p>
@@ -1896,6 +1911,7 @@
           <a:p>
             <a:fld id="{616C4FD7-C31A-4C8B-B854-0E3DE6100231}" type="slidenum">
               <a:rPr lang="en-US" smtClean="0"/>
+              <a:pPr/>
               <a:t>‹#›</a:t>
             </a:fld>
             <a:endParaRPr lang="en-US"/>
@@ -1944,7 +1960,8 @@
           <a:p>
             <a:fld id="{427B8E36-3EEC-47D8-B8BA-CB974FD2B1EA}" type="datetimeFigureOut">
               <a:rPr lang="en-US" smtClean="0"/>
-              <a:t>4/11/2026</a:t>
+              <a:pPr/>
+              <a:t>4/12/2026</a:t>
             </a:fld>
             <a:endParaRPr lang="en-US"/>
           </a:p>
@@ -1986,6 +2003,7 @@
           <a:p>
             <a:fld id="{616C4FD7-C31A-4C8B-B854-0E3DE6100231}" type="slidenum">
               <a:rPr lang="en-US" smtClean="0"/>
+              <a:pPr/>
               <a:t>‹#›</a:t>
             </a:fld>
             <a:endParaRPr lang="en-US"/>
@@ -2216,7 +2234,8 @@
           <a:p>
             <a:fld id="{427B8E36-3EEC-47D8-B8BA-CB974FD2B1EA}" type="datetimeFigureOut">
               <a:rPr lang="en-US" smtClean="0"/>
-              <a:t>4/11/2026</a:t>
+              <a:pPr/>
+              <a:t>4/12/2026</a:t>
             </a:fld>
             <a:endParaRPr lang="en-US"/>
           </a:p>
@@ -2258,6 +2277,7 @@
           <a:p>
             <a:fld id="{616C4FD7-C31A-4C8B-B854-0E3DE6100231}" type="slidenum">
               <a:rPr lang="en-US" smtClean="0"/>
+              <a:pPr/>
               <a:t>‹#›</a:t>
             </a:fld>
             <a:endParaRPr lang="en-US"/>
@@ -2464,7 +2484,8 @@
           <a:p>
             <a:fld id="{427B8E36-3EEC-47D8-B8BA-CB974FD2B1EA}" type="datetimeFigureOut">
               <a:rPr lang="en-US" smtClean="0"/>
-              <a:t>4/11/2026</a:t>
+              <a:pPr/>
+              <a:t>4/12/2026</a:t>
             </a:fld>
             <a:endParaRPr lang="en-US"/>
           </a:p>
@@ -2506,6 +2527,7 @@
           <a:p>
             <a:fld id="{616C4FD7-C31A-4C8B-B854-0E3DE6100231}" type="slidenum">
               <a:rPr lang="en-US" smtClean="0"/>
+              <a:pPr/>
               <a:t>‹#›</a:t>
             </a:fld>
             <a:endParaRPr lang="en-US"/>
@@ -2672,7 +2694,8 @@
           <a:p>
             <a:fld id="{427B8E36-3EEC-47D8-B8BA-CB974FD2B1EA}" type="datetimeFigureOut">
               <a:rPr lang="en-US" smtClean="0"/>
-              <a:t>4/11/2026</a:t>
+              <a:pPr/>
+              <a:t>4/12/2026</a:t>
             </a:fld>
             <a:endParaRPr lang="en-US"/>
           </a:p>
@@ -2750,6 +2773,7 @@
           <a:p>
             <a:fld id="{616C4FD7-C31A-4C8B-B854-0E3DE6100231}" type="slidenum">
               <a:rPr lang="en-US" smtClean="0"/>
+              <a:pPr/>
               <a:t>‹#›</a:t>
             </a:fld>
             <a:endParaRPr lang="en-US"/>
@@ -3658,13 +3682,23 @@
         <p:spPr/>
         <p:txBody>
           <a:bodyPr>
-            <a:normAutofit fontScale="85000" lnSpcReduction="20000"/>
+            <a:normAutofit fontScale="70000" lnSpcReduction="20000"/>
           </a:bodyPr>
           <a:lstStyle/>
           <a:p>
             <a:r>
               <a:rPr lang="en-US" dirty="0" smtClean="0"/>
-              <a:t>Develop a better dataset of ingredients.</a:t>
+              <a:t>Add the ability to use multiple pictures and concatenate the results.</a:t>
+            </a:r>
+          </a:p>
+          <a:p>
+            <a:r>
+              <a:rPr lang="en-US" dirty="0" smtClean="0"/>
+              <a:t>Develop </a:t>
+            </a:r>
+            <a:r>
+              <a:rPr lang="en-US" dirty="0" smtClean="0"/>
+              <a:t>a better dataset of ingredients.</a:t>
             </a:r>
           </a:p>
           <a:p>
@@ -3682,7 +3716,26 @@
           <a:p>
             <a:r>
               <a:rPr lang="en-US" dirty="0" smtClean="0"/>
-              <a:t>Add the ability to change the number of recipes to be retrieved.</a:t>
+              <a:t>Add the ability to update the </a:t>
+            </a:r>
+            <a:r>
+              <a:rPr lang="en-US" dirty="0" err="1" smtClean="0"/>
+              <a:t>ChatGPT</a:t>
+            </a:r>
+            <a:r>
+              <a:rPr lang="en-US" dirty="0" smtClean="0"/>
+              <a:t> API Key to the interface.</a:t>
+            </a:r>
+            <a:endParaRPr lang="en-US" smtClean="0"/>
+          </a:p>
+          <a:p>
+            <a:r>
+              <a:rPr lang="en-US" smtClean="0"/>
+              <a:t>Add </a:t>
+            </a:r>
+            <a:r>
+              <a:rPr lang="en-US" dirty="0" smtClean="0"/>
+              <a:t>the ability to change the number of recipes to be retrieved.</a:t>
             </a:r>
           </a:p>
           <a:p>
@@ -3706,9 +3759,12 @@
           <a:p>
             <a:r>
               <a:rPr lang="en-US" dirty="0" smtClean="0"/>
-              <a:t>Make it into a phone application using the cloud to handle the A.I. portion.</a:t>
-            </a:r>
-            <a:endParaRPr lang="en-US" dirty="0"/>
+              <a:t>Make it into a phone application using the cloud to handle the A.I. portion</a:t>
+            </a:r>
+            <a:r>
+              <a:rPr lang="en-US" dirty="0" smtClean="0"/>
+              <a:t>.</a:t>
+            </a:r>
           </a:p>
         </p:txBody>
       </p:sp>

</xml_diff>

<commit_message>
Added method to add an API key for ChatGPT.
If there is no environment variable, then a text box will open that can take an API Key.  Hitting there corresponding button will load the key so you can get your recipes.
Updated presentation.
</commit_message>
<xml_diff>
--- a/Presentation/Recipes_from_Pictures.pptx
+++ b/Presentation/Recipes_from_Pictures.pptx
@@ -10,9 +10,10 @@
     <p:sldId id="258" r:id="rId4"/>
     <p:sldId id="259" r:id="rId5"/>
     <p:sldId id="260" r:id="rId6"/>
-    <p:sldId id="261" r:id="rId7"/>
-    <p:sldId id="262" r:id="rId8"/>
-    <p:sldId id="263" r:id="rId9"/>
+    <p:sldId id="264" r:id="rId7"/>
+    <p:sldId id="261" r:id="rId8"/>
+    <p:sldId id="262" r:id="rId9"/>
+    <p:sldId id="263" r:id="rId10"/>
   </p:sldIdLst>
   <p:sldSz cx="9144000" cy="6858000" type="screen4x3"/>
   <p:notesSz cx="6858000" cy="9144000"/>
@@ -3482,6 +3483,141 @@
           <a:p>
             <a:r>
               <a:rPr lang="en-US" dirty="0" smtClean="0"/>
+              <a:t>If API Key to </a:t>
+            </a:r>
+            <a:r>
+              <a:rPr lang="en-US" dirty="0" err="1" smtClean="0"/>
+              <a:t>ChatGPT</a:t>
+            </a:r>
+            <a:r>
+              <a:rPr lang="en-US" dirty="0" smtClean="0"/>
+              <a:t> is Missing</a:t>
+            </a:r>
+            <a:endParaRPr lang="en-US" dirty="0"/>
+          </a:p>
+        </p:txBody>
+      </p:sp>
+      <p:pic>
+        <p:nvPicPr>
+          <p:cNvPr id="4" name="Content Placeholder 3" descr="Interface_no_API.png"/>
+          <p:cNvPicPr>
+            <a:picLocks noGrp="1" noChangeAspect="1"/>
+          </p:cNvPicPr>
+          <p:nvPr>
+            <p:ph idx="1"/>
+          </p:nvPr>
+        </p:nvPicPr>
+        <p:blipFill>
+          <a:blip r:embed="rId2" cstate="print"/>
+          <a:stretch>
+            <a:fillRect/>
+          </a:stretch>
+        </p:blipFill>
+        <p:spPr>
+          <a:xfrm>
+            <a:off x="762000" y="1600200"/>
+            <a:ext cx="3011404" cy="4525963"/>
+          </a:xfrm>
+        </p:spPr>
+      </p:pic>
+      <p:sp>
+        <p:nvSpPr>
+          <p:cNvPr id="5" name="TextBox 4"/>
+          <p:cNvSpPr txBox="1"/>
+          <p:nvPr/>
+        </p:nvSpPr>
+        <p:spPr>
+          <a:xfrm>
+            <a:off x="4648200" y="1981200"/>
+            <a:ext cx="3657600" cy="2031325"/>
+          </a:xfrm>
+          <a:prstGeom prst="rect">
+            <a:avLst/>
+          </a:prstGeom>
+          <a:noFill/>
+        </p:spPr>
+        <p:txBody>
+          <a:bodyPr wrap="square" rtlCol="0">
+            <a:spAutoFit/>
+          </a:bodyPr>
+          <a:lstStyle/>
+          <a:p>
+            <a:r>
+              <a:rPr lang="en-US" dirty="0" smtClean="0"/>
+              <a:t>If there is no environment variable for the </a:t>
+            </a:r>
+            <a:r>
+              <a:rPr lang="en-US" dirty="0" err="1" smtClean="0"/>
+              <a:t>ChatGPT</a:t>
+            </a:r>
+            <a:r>
+              <a:rPr lang="en-US" dirty="0" smtClean="0"/>
+              <a:t> API key, then a text box will open so you can paste the key into it.  Then click on the button to “Get API Key.”</a:t>
+            </a:r>
+          </a:p>
+          <a:p>
+            <a:r>
+              <a:rPr lang="en-US" dirty="0" smtClean="0"/>
+              <a:t>Now try the “Ask </a:t>
+            </a:r>
+            <a:r>
+              <a:rPr lang="en-US" dirty="0" err="1" smtClean="0"/>
+              <a:t>ChatGPT</a:t>
+            </a:r>
+            <a:r>
+              <a:rPr lang="en-US" dirty="0" smtClean="0"/>
+              <a:t> for Ideas” again to get </a:t>
+            </a:r>
+            <a:r>
+              <a:rPr lang="en-US" smtClean="0"/>
+              <a:t>your recipes.</a:t>
+            </a:r>
+            <a:endParaRPr lang="en-US" dirty="0"/>
+          </a:p>
+        </p:txBody>
+      </p:sp>
+    </p:spTree>
+  </p:cSld>
+  <p:clrMapOvr>
+    <a:masterClrMapping/>
+  </p:clrMapOvr>
+</p:sld>
+</file>
+
+<file path=ppt/slides/slide7.xml><?xml version="1.0" encoding="utf-8"?>
+<p:sld xmlns:a="http://schemas.openxmlformats.org/drawingml/2006/main" xmlns:r="http://schemas.openxmlformats.org/officeDocument/2006/relationships" xmlns:p="http://schemas.openxmlformats.org/presentationml/2006/main">
+  <p:cSld>
+    <p:spTree>
+      <p:nvGrpSpPr>
+        <p:cNvPr id="1" name=""/>
+        <p:cNvGrpSpPr/>
+        <p:nvPr/>
+      </p:nvGrpSpPr>
+      <p:grpSpPr>
+        <a:xfrm>
+          <a:off x="0" y="0"/>
+          <a:ext cx="0" cy="0"/>
+          <a:chOff x="0" y="0"/>
+          <a:chExt cx="0" cy="0"/>
+        </a:xfrm>
+      </p:grpSpPr>
+      <p:sp>
+        <p:nvSpPr>
+          <p:cNvPr id="2" name="Title 1"/>
+          <p:cNvSpPr>
+            <a:spLocks noGrp="1"/>
+          </p:cNvSpPr>
+          <p:nvPr>
+            <p:ph type="title"/>
+          </p:nvPr>
+        </p:nvSpPr>
+        <p:spPr/>
+        <p:txBody>
+          <a:bodyPr/>
+          <a:lstStyle/>
+          <a:p>
+            <a:r>
+              <a:rPr lang="en-US" dirty="0" smtClean="0"/>
               <a:t>Not Always Perfect</a:t>
             </a:r>
             <a:endParaRPr lang="en-US" dirty="0"/>
@@ -3629,7 +3765,7 @@
 </p:sld>
 </file>
 
-<file path=ppt/slides/slide7.xml><?xml version="1.0" encoding="utf-8"?>
+<file path=ppt/slides/slide8.xml><?xml version="1.0" encoding="utf-8"?>
 <p:sld xmlns:a="http://schemas.openxmlformats.org/drawingml/2006/main" xmlns:r="http://schemas.openxmlformats.org/officeDocument/2006/relationships" xmlns:p="http://schemas.openxmlformats.org/presentationml/2006/main">
   <p:cSld>
     <p:spTree>
@@ -3694,11 +3830,7 @@
           <a:p>
             <a:r>
               <a:rPr lang="en-US" dirty="0" smtClean="0"/>
-              <a:t>Develop </a:t>
-            </a:r>
-            <a:r>
-              <a:rPr lang="en-US" dirty="0" smtClean="0"/>
-              <a:t>a better dataset of ingredients.</a:t>
+              <a:t>Develop a better dataset of ingredients.</a:t>
             </a:r>
           </a:p>
           <a:p>
@@ -3716,21 +3848,6 @@
           <a:p>
             <a:r>
               <a:rPr lang="en-US" dirty="0" smtClean="0"/>
-              <a:t>Add the ability to update the </a:t>
-            </a:r>
-            <a:r>
-              <a:rPr lang="en-US" dirty="0" err="1" smtClean="0"/>
-              <a:t>ChatGPT</a:t>
-            </a:r>
-            <a:r>
-              <a:rPr lang="en-US" dirty="0" smtClean="0"/>
-              <a:t> API Key to the interface.</a:t>
-            </a:r>
-            <a:endParaRPr lang="en-US" smtClean="0"/>
-          </a:p>
-          <a:p>
-            <a:r>
-              <a:rPr lang="en-US" smtClean="0"/>
               <a:t>Add </a:t>
             </a:r>
             <a:r>
@@ -3759,11 +3876,7 @@
           <a:p>
             <a:r>
               <a:rPr lang="en-US" dirty="0" smtClean="0"/>
-              <a:t>Make it into a phone application using the cloud to handle the A.I. portion</a:t>
-            </a:r>
-            <a:r>
-              <a:rPr lang="en-US" dirty="0" smtClean="0"/>
-              <a:t>.</a:t>
+              <a:t>Make it into a phone application using the cloud to handle the A.I. portion.</a:t>
             </a:r>
           </a:p>
         </p:txBody>
@@ -3776,7 +3889,7 @@
 </p:sld>
 </file>
 
-<file path=ppt/slides/slide8.xml><?xml version="1.0" encoding="utf-8"?>
+<file path=ppt/slides/slide9.xml><?xml version="1.0" encoding="utf-8"?>
 <p:sld xmlns:a="http://schemas.openxmlformats.org/drawingml/2006/main" xmlns:r="http://schemas.openxmlformats.org/officeDocument/2006/relationships" xmlns:p="http://schemas.openxmlformats.org/presentationml/2006/main">
   <p:cSld>
     <p:spTree>

</xml_diff>

<commit_message>
Added video for presentation.
</commit_message>
<xml_diff>
--- a/Presentation/Recipes_from_Pictures.pptx
+++ b/Presentation/Recipes_from_Pictures.pptx
@@ -12,8 +12,9 @@
     <p:sldId id="260" r:id="rId6"/>
     <p:sldId id="264" r:id="rId7"/>
     <p:sldId id="261" r:id="rId8"/>
-    <p:sldId id="262" r:id="rId9"/>
-    <p:sldId id="263" r:id="rId10"/>
+    <p:sldId id="265" r:id="rId9"/>
+    <p:sldId id="262" r:id="rId10"/>
+    <p:sldId id="263" r:id="rId11"/>
   </p:sldIdLst>
   <p:sldSz cx="9144000" cy="6858000" type="screen4x3"/>
   <p:notesSz cx="6858000" cy="9144000"/>
@@ -3107,23 +3108,282 @@
           <a:p>
             <a:r>
               <a:rPr lang="en-US" dirty="0" smtClean="0"/>
-              <a:t>My Wife Made Me do This.</a:t>
-            </a:r>
-          </a:p>
-          <a:p>
+              <a:t>My Wife Made Me </a:t>
+            </a:r>
             <a:r>
               <a:rPr lang="en-US" dirty="0" smtClean="0"/>
-              <a:t>Bill McKee</a:t>
+              <a:t>Do </a:t>
+            </a:r>
+            <a:r>
+              <a:rPr lang="en-US" dirty="0" smtClean="0"/>
+              <a:t>This.</a:t>
+            </a:r>
+          </a:p>
+          <a:p>
+            <a:r>
+              <a:rPr lang="en-US" dirty="0" smtClean="0"/>
+              <a:t>By: Bill </a:t>
+            </a:r>
+            <a:r>
+              <a:rPr lang="en-US" dirty="0" smtClean="0"/>
+              <a:t>McKee</a:t>
             </a:r>
             <a:endParaRPr lang="en-US" dirty="0"/>
           </a:p>
         </p:txBody>
       </p:sp>
+      <p:pic>
+        <p:nvPicPr>
+          <p:cNvPr id="7" name="~PP981.WAV">
+            <a:hlinkClick r:id="" action="ppaction://media"/>
+          </p:cNvPr>
+          <p:cNvPicPr>
+            <a:picLocks noRot="1" noChangeAspect="1"/>
+          </p:cNvPicPr>
+          <p:nvPr>
+            <a:wavAudioFile r:embed="rId1" name="~PP981.WAV"/>
+          </p:nvPr>
+        </p:nvPicPr>
+        <p:blipFill>
+          <a:blip r:embed="rId3" cstate="print"/>
+          <a:stretch>
+            <a:fillRect/>
+          </a:stretch>
+        </p:blipFill>
+        <p:spPr>
+          <a:xfrm>
+            <a:off x="8763000" y="6477000"/>
+            <a:ext cx="304800" cy="304800"/>
+          </a:xfrm>
+          <a:prstGeom prst="rect">
+            <a:avLst/>
+          </a:prstGeom>
+        </p:spPr>
+      </p:pic>
     </p:spTree>
   </p:cSld>
   <p:clrMapOvr>
     <a:masterClrMapping/>
   </p:clrMapOvr>
+  <p:timing>
+    <p:tnLst>
+      <p:par>
+        <p:cTn id="1" dur="indefinite" restart="never" nodeType="tmRoot">
+          <p:childTnLst>
+            <p:seq concurrent="1" nextAc="seek">
+              <p:cTn id="2" dur="indefinite" nodeType="mainSeq">
+                <p:childTnLst>
+                  <p:par>
+                    <p:cTn id="3" fill="hold">
+                      <p:stCondLst>
+                        <p:cond delay="indefinite"/>
+                        <p:cond evt="onBegin" delay="0">
+                          <p:tn val="2"/>
+                        </p:cond>
+                      </p:stCondLst>
+                      <p:childTnLst>
+                        <p:par>
+                          <p:cTn id="4" fill="hold">
+                            <p:stCondLst>
+                              <p:cond delay="0"/>
+                            </p:stCondLst>
+                            <p:childTnLst>
+                              <p:par>
+                                <p:cTn id="5" presetID="1" presetClass="mediacall" presetSubtype="0" fill="hold" nodeType="afterEffect">
+                                  <p:stCondLst>
+                                    <p:cond delay="0"/>
+                                  </p:stCondLst>
+                                  <p:childTnLst>
+                                    <p:cmd type="call" cmd="playFrom(0.0)">
+                                      <p:cBhvr>
+                                        <p:cTn id="6" dur="1" fill="hold"/>
+                                        <p:tgtEl>
+                                          <p:spTgt spid="7"/>
+                                        </p:tgtEl>
+                                      </p:cBhvr>
+                                    </p:cmd>
+                                  </p:childTnLst>
+                                </p:cTn>
+                              </p:par>
+                            </p:childTnLst>
+                          </p:cTn>
+                        </p:par>
+                      </p:childTnLst>
+                    </p:cTn>
+                  </p:par>
+                </p:childTnLst>
+              </p:cTn>
+              <p:prevCondLst>
+                <p:cond evt="onPrev" delay="0">
+                  <p:tgtEl>
+                    <p:sldTgt/>
+                  </p:tgtEl>
+                </p:cond>
+              </p:prevCondLst>
+              <p:nextCondLst>
+                <p:cond evt="onNext" delay="0">
+                  <p:tgtEl>
+                    <p:sldTgt/>
+                  </p:tgtEl>
+                </p:cond>
+              </p:nextCondLst>
+            </p:seq>
+            <p:audio isNarration="1">
+              <p:cMediaNode showWhenStopped="0">
+                <p:cTn id="7" fill="hold" display="0">
+                  <p:stCondLst>
+                    <p:cond delay="indefinite"/>
+                  </p:stCondLst>
+                  <p:endCondLst>
+                    <p:cond evt="onPrev" delay="0">
+                      <p:tgtEl>
+                        <p:sldTgt/>
+                      </p:tgtEl>
+                    </p:cond>
+                    <p:cond evt="onStopAudio" delay="0">
+                      <p:tgtEl>
+                        <p:sldTgt/>
+                      </p:tgtEl>
+                    </p:cond>
+                  </p:endCondLst>
+                </p:cTn>
+                <p:tgtEl>
+                  <p:spTgt spid="7"/>
+                </p:tgtEl>
+              </p:cMediaNode>
+            </p:audio>
+          </p:childTnLst>
+        </p:cTn>
+      </p:par>
+    </p:tnLst>
+  </p:timing>
+</p:sld>
+</file>
+
+<file path=ppt/slides/slide10.xml><?xml version="1.0" encoding="utf-8"?>
+<p:sld xmlns:a="http://schemas.openxmlformats.org/drawingml/2006/main" xmlns:r="http://schemas.openxmlformats.org/officeDocument/2006/relationships" xmlns:p="http://schemas.openxmlformats.org/presentationml/2006/main">
+  <p:cSld>
+    <p:spTree>
+      <p:nvGrpSpPr>
+        <p:cNvPr id="1" name=""/>
+        <p:cNvGrpSpPr/>
+        <p:nvPr/>
+      </p:nvGrpSpPr>
+      <p:grpSpPr>
+        <a:xfrm>
+          <a:off x="0" y="0"/>
+          <a:ext cx="0" cy="0"/>
+          <a:chOff x="0" y="0"/>
+          <a:chExt cx="0" cy="0"/>
+        </a:xfrm>
+      </p:grpSpPr>
+      <p:sp>
+        <p:nvSpPr>
+          <p:cNvPr id="2" name="Title 1"/>
+          <p:cNvSpPr>
+            <a:spLocks noGrp="1"/>
+          </p:cNvSpPr>
+          <p:nvPr>
+            <p:ph type="title"/>
+          </p:nvPr>
+        </p:nvSpPr>
+        <p:spPr/>
+        <p:txBody>
+          <a:bodyPr/>
+          <a:lstStyle/>
+          <a:p>
+            <a:r>
+              <a:rPr lang="en-US" dirty="0" smtClean="0"/>
+              <a:t>References</a:t>
+            </a:r>
+            <a:endParaRPr lang="en-US" dirty="0"/>
+          </a:p>
+        </p:txBody>
+      </p:sp>
+      <p:sp>
+        <p:nvSpPr>
+          <p:cNvPr id="3" name="Content Placeholder 2"/>
+          <p:cNvSpPr>
+            <a:spLocks noGrp="1"/>
+          </p:cNvSpPr>
+          <p:nvPr>
+            <p:ph idx="1"/>
+          </p:nvPr>
+        </p:nvSpPr>
+        <p:spPr/>
+        <p:txBody>
+          <a:bodyPr>
+            <a:normAutofit fontScale="92500" lnSpcReduction="10000"/>
+          </a:bodyPr>
+          <a:lstStyle/>
+          <a:p>
+            <a:r>
+              <a:rPr lang="en-US" dirty="0" smtClean="0">
+                <a:hlinkClick r:id="rId2"/>
+              </a:rPr>
+              <a:t>https://platform.ultralytics.com/</a:t>
+            </a:r>
+            <a:endParaRPr lang="en-US" dirty="0" smtClean="0"/>
+          </a:p>
+          <a:p>
+            <a:r>
+              <a:rPr lang="en-US" dirty="0" smtClean="0">
+                <a:hlinkClick r:id="rId3"/>
+              </a:rPr>
+              <a:t>https://universe.roboflow.com/food-recipe-ingredient-images-0gnku/food-ingredients-dataset</a:t>
+            </a:r>
+            <a:endParaRPr lang="en-US" dirty="0" smtClean="0"/>
+          </a:p>
+          <a:p>
+            <a:r>
+              <a:rPr lang="en-US" dirty="0" smtClean="0">
+                <a:hlinkClick r:id="rId4"/>
+              </a:rPr>
+              <a:t>https://www.themealdb.com/</a:t>
+            </a:r>
+            <a:endParaRPr lang="en-US" dirty="0" smtClean="0"/>
+          </a:p>
+          <a:p>
+            <a:r>
+              <a:rPr lang="en-US" dirty="0" smtClean="0">
+                <a:hlinkClick r:id="rId5"/>
+              </a:rPr>
+              <a:t>https://openai.com/</a:t>
+            </a:r>
+            <a:endParaRPr lang="en-US" dirty="0" smtClean="0"/>
+          </a:p>
+          <a:p>
+            <a:r>
+              <a:rPr lang="en-US" dirty="0" smtClean="0">
+                <a:hlinkClick r:id="rId6"/>
+              </a:rPr>
+              <a:t>https://www.nvidia.com/en-us/autonomous-machines/embedded-systems/jetson-thor/</a:t>
+            </a:r>
+            <a:endParaRPr lang="en-US" dirty="0" smtClean="0"/>
+          </a:p>
+          <a:p>
+            <a:r>
+              <a:rPr lang="en-US" dirty="0" smtClean="0">
+                <a:hlinkClick r:id="rId7"/>
+              </a:rPr>
+              <a:t>https://colab.research.google.com/</a:t>
+            </a:r>
+            <a:endParaRPr lang="en-US" dirty="0" smtClean="0"/>
+          </a:p>
+        </p:txBody>
+      </p:sp>
+    </p:spTree>
+  </p:cSld>
+  <p:clrMapOvr>
+    <a:masterClrMapping/>
+  </p:clrMapOvr>
+  <p:timing>
+    <p:tnLst>
+      <p:par>
+        <p:cTn id="1" dur="indefinite" restart="never" nodeType="tmRoot"/>
+      </p:par>
+    </p:tnLst>
+  </p:timing>
 </p:sld>
 </file>
 
@@ -3196,11 +3456,131 @@
           </a:p>
         </p:txBody>
       </p:sp>
+      <p:pic>
+        <p:nvPicPr>
+          <p:cNvPr id="5" name="~PP2512.WAV">
+            <a:hlinkClick r:id="" action="ppaction://media"/>
+          </p:cNvPr>
+          <p:cNvPicPr>
+            <a:picLocks noRot="1" noChangeAspect="1"/>
+          </p:cNvPicPr>
+          <p:nvPr>
+            <a:wavAudioFile r:embed="rId1" name="~PP2512.WAV"/>
+          </p:nvPr>
+        </p:nvPicPr>
+        <p:blipFill>
+          <a:blip r:embed="rId3" cstate="print"/>
+          <a:stretch>
+            <a:fillRect/>
+          </a:stretch>
+        </p:blipFill>
+        <p:spPr>
+          <a:xfrm>
+            <a:off x="8763000" y="6477000"/>
+            <a:ext cx="304800" cy="304800"/>
+          </a:xfrm>
+          <a:prstGeom prst="rect">
+            <a:avLst/>
+          </a:prstGeom>
+        </p:spPr>
+      </p:pic>
     </p:spTree>
   </p:cSld>
   <p:clrMapOvr>
     <a:masterClrMapping/>
   </p:clrMapOvr>
+  <p:timing>
+    <p:tnLst>
+      <p:par>
+        <p:cTn id="1" dur="indefinite" restart="never" nodeType="tmRoot">
+          <p:childTnLst>
+            <p:seq concurrent="1" nextAc="seek">
+              <p:cTn id="2" dur="indefinite" nodeType="mainSeq">
+                <p:childTnLst>
+                  <p:par>
+                    <p:cTn id="3" fill="hold">
+                      <p:stCondLst>
+                        <p:cond delay="indefinite"/>
+                        <p:cond evt="onBegin" delay="0">
+                          <p:tn val="2"/>
+                        </p:cond>
+                      </p:stCondLst>
+                      <p:childTnLst>
+                        <p:par>
+                          <p:cTn id="4" fill="hold">
+                            <p:stCondLst>
+                              <p:cond delay="0"/>
+                            </p:stCondLst>
+                            <p:childTnLst>
+                              <p:par>
+                                <p:cTn id="5" presetID="1" presetClass="mediacall" presetSubtype="0" fill="hold" nodeType="afterEffect">
+                                  <p:stCondLst>
+                                    <p:cond delay="0"/>
+                                  </p:stCondLst>
+                                  <p:childTnLst>
+                                    <p:cmd type="call" cmd="playFrom(0.0)">
+                                      <p:cBhvr>
+                                        <p:cTn id="6" dur="1" fill="hold"/>
+                                        <p:tgtEl>
+                                          <p:spTgt spid="5"/>
+                                        </p:tgtEl>
+                                      </p:cBhvr>
+                                    </p:cmd>
+                                  </p:childTnLst>
+                                </p:cTn>
+                              </p:par>
+                            </p:childTnLst>
+                          </p:cTn>
+                        </p:par>
+                      </p:childTnLst>
+                    </p:cTn>
+                  </p:par>
+                </p:childTnLst>
+              </p:cTn>
+              <p:prevCondLst>
+                <p:cond evt="onPrev" delay="0">
+                  <p:tgtEl>
+                    <p:sldTgt/>
+                  </p:tgtEl>
+                </p:cond>
+              </p:prevCondLst>
+              <p:nextCondLst>
+                <p:cond evt="onNext" delay="0">
+                  <p:tgtEl>
+                    <p:sldTgt/>
+                  </p:tgtEl>
+                </p:cond>
+              </p:nextCondLst>
+            </p:seq>
+            <p:audio isNarration="1">
+              <p:cMediaNode showWhenStopped="0">
+                <p:cTn id="7" fill="hold" display="0">
+                  <p:stCondLst>
+                    <p:cond delay="indefinite"/>
+                  </p:stCondLst>
+                  <p:endCondLst>
+                    <p:cond evt="onPrev" delay="0">
+                      <p:tgtEl>
+                        <p:sldTgt/>
+                      </p:tgtEl>
+                    </p:cond>
+                    <p:cond evt="onStopAudio" delay="0">
+                      <p:tgtEl>
+                        <p:sldTgt/>
+                      </p:tgtEl>
+                    </p:cond>
+                  </p:endCondLst>
+                </p:cTn>
+                <p:tgtEl>
+                  <p:spTgt spid="5"/>
+                </p:tgtEl>
+              </p:cMediaNode>
+            </p:audio>
+          </p:childTnLst>
+        </p:cTn>
+      </p:par>
+    </p:tnLst>
+  </p:timing>
 </p:sld>
 </file>
 
@@ -3299,11 +3679,131 @@
           </a:p>
         </p:txBody>
       </p:sp>
+      <p:pic>
+        <p:nvPicPr>
+          <p:cNvPr id="4" name="~PP3981.WAV">
+            <a:hlinkClick r:id="" action="ppaction://media"/>
+          </p:cNvPr>
+          <p:cNvPicPr>
+            <a:picLocks noRot="1" noChangeAspect="1"/>
+          </p:cNvPicPr>
+          <p:nvPr>
+            <a:wavAudioFile r:embed="rId1" name="~PP3981.WAV"/>
+          </p:nvPr>
+        </p:nvPicPr>
+        <p:blipFill>
+          <a:blip r:embed="rId3" cstate="print"/>
+          <a:stretch>
+            <a:fillRect/>
+          </a:stretch>
+        </p:blipFill>
+        <p:spPr>
+          <a:xfrm>
+            <a:off x="8763000" y="6477000"/>
+            <a:ext cx="304800" cy="304800"/>
+          </a:xfrm>
+          <a:prstGeom prst="rect">
+            <a:avLst/>
+          </a:prstGeom>
+        </p:spPr>
+      </p:pic>
     </p:spTree>
   </p:cSld>
   <p:clrMapOvr>
     <a:masterClrMapping/>
   </p:clrMapOvr>
+  <p:timing>
+    <p:tnLst>
+      <p:par>
+        <p:cTn id="1" dur="indefinite" restart="never" nodeType="tmRoot">
+          <p:childTnLst>
+            <p:seq concurrent="1" nextAc="seek">
+              <p:cTn id="2" dur="indefinite" nodeType="mainSeq">
+                <p:childTnLst>
+                  <p:par>
+                    <p:cTn id="3" fill="hold">
+                      <p:stCondLst>
+                        <p:cond delay="indefinite"/>
+                        <p:cond evt="onBegin" delay="0">
+                          <p:tn val="2"/>
+                        </p:cond>
+                      </p:stCondLst>
+                      <p:childTnLst>
+                        <p:par>
+                          <p:cTn id="4" fill="hold">
+                            <p:stCondLst>
+                              <p:cond delay="0"/>
+                            </p:stCondLst>
+                            <p:childTnLst>
+                              <p:par>
+                                <p:cTn id="5" presetID="1" presetClass="mediacall" presetSubtype="0" fill="hold" nodeType="afterEffect">
+                                  <p:stCondLst>
+                                    <p:cond delay="0"/>
+                                  </p:stCondLst>
+                                  <p:childTnLst>
+                                    <p:cmd type="call" cmd="playFrom(0.0)">
+                                      <p:cBhvr>
+                                        <p:cTn id="6" dur="1" fill="hold"/>
+                                        <p:tgtEl>
+                                          <p:spTgt spid="4"/>
+                                        </p:tgtEl>
+                                      </p:cBhvr>
+                                    </p:cmd>
+                                  </p:childTnLst>
+                                </p:cTn>
+                              </p:par>
+                            </p:childTnLst>
+                          </p:cTn>
+                        </p:par>
+                      </p:childTnLst>
+                    </p:cTn>
+                  </p:par>
+                </p:childTnLst>
+              </p:cTn>
+              <p:prevCondLst>
+                <p:cond evt="onPrev" delay="0">
+                  <p:tgtEl>
+                    <p:sldTgt/>
+                  </p:tgtEl>
+                </p:cond>
+              </p:prevCondLst>
+              <p:nextCondLst>
+                <p:cond evt="onNext" delay="0">
+                  <p:tgtEl>
+                    <p:sldTgt/>
+                  </p:tgtEl>
+                </p:cond>
+              </p:nextCondLst>
+            </p:seq>
+            <p:audio isNarration="1">
+              <p:cMediaNode showWhenStopped="0">
+                <p:cTn id="7" fill="hold" display="0">
+                  <p:stCondLst>
+                    <p:cond delay="indefinite"/>
+                  </p:stCondLst>
+                  <p:endCondLst>
+                    <p:cond evt="onPrev" delay="0">
+                      <p:tgtEl>
+                        <p:sldTgt/>
+                      </p:tgtEl>
+                    </p:cond>
+                    <p:cond evt="onStopAudio" delay="0">
+                      <p:tgtEl>
+                        <p:sldTgt/>
+                      </p:tgtEl>
+                    </p:cond>
+                  </p:endCondLst>
+                </p:cTn>
+                <p:tgtEl>
+                  <p:spTgt spid="4"/>
+                </p:tgtEl>
+              </p:cMediaNode>
+            </p:audio>
+          </p:childTnLst>
+        </p:cTn>
+      </p:par>
+    </p:tnLst>
+  </p:timing>
 </p:sld>
 </file>
 
@@ -3375,6 +3875,13 @@
   <p:clrMapOvr>
     <a:masterClrMapping/>
   </p:clrMapOvr>
+  <p:timing>
+    <p:tnLst>
+      <p:par>
+        <p:cTn id="1" dur="indefinite" restart="never" nodeType="tmRoot"/>
+      </p:par>
+    </p:tnLst>
+  </p:timing>
 </p:sld>
 </file>
 
@@ -3794,90 +4301,133 @@
         </p:nvSpPr>
         <p:spPr/>
         <p:txBody>
-          <a:bodyPr/>
+          <a:bodyPr>
+            <a:normAutofit/>
+          </a:bodyPr>
           <a:lstStyle/>
           <a:p>
             <a:r>
               <a:rPr lang="en-US" dirty="0" smtClean="0"/>
-              <a:t>Future Improvements</a:t>
+              <a:t>Some Videos of the Program in Use</a:t>
             </a:r>
             <a:endParaRPr lang="en-US" dirty="0"/>
           </a:p>
         </p:txBody>
       </p:sp>
-      <p:sp>
-        <p:nvSpPr>
-          <p:cNvPr id="3" name="Content Placeholder 2"/>
-          <p:cNvSpPr>
-            <a:spLocks noGrp="1"/>
-          </p:cNvSpPr>
+      <p:pic>
+        <p:nvPicPr>
+          <p:cNvPr id="4" name="NormalProcedure.mp4">
+            <a:hlinkClick r:id="" action="ppaction://media"/>
+          </p:cNvPr>
+          <p:cNvPicPr>
+            <a:picLocks noGrp="1" noRot="1" noChangeAspect="1"/>
+          </p:cNvPicPr>
           <p:nvPr>
             <p:ph idx="1"/>
-          </p:nvPr>
-        </p:nvSpPr>
-        <p:spPr/>
-        <p:txBody>
-          <a:bodyPr>
-            <a:normAutofit fontScale="70000" lnSpcReduction="20000"/>
+            <a:videoFile r:link="rId1"/>
+          </p:nvPr>
+        </p:nvPicPr>
+        <p:blipFill>
+          <a:blip r:embed="rId4" cstate="print"/>
+          <a:stretch>
+            <a:fillRect/>
+          </a:stretch>
+        </p:blipFill>
+        <p:spPr>
+          <a:xfrm>
+            <a:off x="685800" y="1905000"/>
+            <a:ext cx="3733800" cy="4038600"/>
+          </a:xfrm>
+          <a:prstGeom prst="rect">
+            <a:avLst/>
+          </a:prstGeom>
+        </p:spPr>
+      </p:pic>
+      <p:pic>
+        <p:nvPicPr>
+          <p:cNvPr id="5" name="NoAPIProcedure.mp4">
+            <a:hlinkClick r:id="" action="ppaction://media"/>
+          </p:cNvPr>
+          <p:cNvPicPr>
+            <a:picLocks noRot="1" noChangeAspect="1"/>
+          </p:cNvPicPr>
+          <p:nvPr>
+            <a:videoFile r:link="rId2"/>
+          </p:nvPr>
+        </p:nvPicPr>
+        <p:blipFill>
+          <a:blip r:embed="rId4" cstate="print"/>
+          <a:stretch>
+            <a:fillRect/>
+          </a:stretch>
+        </p:blipFill>
+        <p:spPr>
+          <a:xfrm>
+            <a:off x="4876800" y="1905000"/>
+            <a:ext cx="3581400" cy="4038600"/>
+          </a:xfrm>
+          <a:prstGeom prst="rect">
+            <a:avLst/>
+          </a:prstGeom>
+        </p:spPr>
+      </p:pic>
+      <p:sp>
+        <p:nvSpPr>
+          <p:cNvPr id="6" name="TextBox 5"/>
+          <p:cNvSpPr txBox="1"/>
+          <p:nvPr/>
+        </p:nvSpPr>
+        <p:spPr>
+          <a:xfrm>
+            <a:off x="1219200" y="6172200"/>
+            <a:ext cx="1883401" cy="369332"/>
+          </a:xfrm>
+          <a:prstGeom prst="rect">
+            <a:avLst/>
+          </a:prstGeom>
+          <a:noFill/>
+        </p:spPr>
+        <p:txBody>
+          <a:bodyPr wrap="none" rtlCol="0">
+            <a:spAutoFit/>
           </a:bodyPr>
           <a:lstStyle/>
           <a:p>
             <a:r>
               <a:rPr lang="en-US" dirty="0" smtClean="0"/>
-              <a:t>Add the ability to use multiple pictures and concatenate the results.</a:t>
-            </a:r>
-          </a:p>
+              <a:t>Normal Operation</a:t>
+            </a:r>
+            <a:endParaRPr lang="en-US" dirty="0"/>
+          </a:p>
+        </p:txBody>
+      </p:sp>
+      <p:sp>
+        <p:nvSpPr>
+          <p:cNvPr id="7" name="TextBox 6"/>
+          <p:cNvSpPr txBox="1"/>
+          <p:nvPr/>
+        </p:nvSpPr>
+        <p:spPr>
+          <a:xfrm>
+            <a:off x="5867400" y="6172200"/>
+            <a:ext cx="2286000" cy="369332"/>
+          </a:xfrm>
+          <a:prstGeom prst="rect">
+            <a:avLst/>
+          </a:prstGeom>
+          <a:noFill/>
+        </p:spPr>
+        <p:txBody>
+          <a:bodyPr wrap="square" rtlCol="0">
+            <a:spAutoFit/>
+          </a:bodyPr>
+          <a:lstStyle/>
           <a:p>
             <a:r>
               <a:rPr lang="en-US" dirty="0" smtClean="0"/>
-              <a:t>Develop a better dataset of ingredients.</a:t>
-            </a:r>
-          </a:p>
-          <a:p>
-            <a:r>
-              <a:rPr lang="en-US" dirty="0" smtClean="0"/>
-              <a:t>Improve the object detection model.</a:t>
-            </a:r>
-          </a:p>
-          <a:p>
-            <a:r>
-              <a:rPr lang="en-US" dirty="0" smtClean="0"/>
-              <a:t>Add save and print capabilities for the recipes.</a:t>
-            </a:r>
-          </a:p>
-          <a:p>
-            <a:r>
-              <a:rPr lang="en-US" dirty="0" smtClean="0"/>
-              <a:t>Add </a:t>
-            </a:r>
-            <a:r>
-              <a:rPr lang="en-US" dirty="0" smtClean="0"/>
-              <a:t>the ability to change the number of recipes to be retrieved.</a:t>
-            </a:r>
-          </a:p>
-          <a:p>
-            <a:r>
-              <a:rPr lang="en-US" dirty="0" smtClean="0"/>
-              <a:t>Add the ability to get specialized recipes based on dietary constraints and meal type.</a:t>
-            </a:r>
-          </a:p>
-          <a:p>
-            <a:r>
-              <a:rPr lang="en-US" dirty="0" smtClean="0"/>
-              <a:t>Place each recipe in a different tab of a text box.</a:t>
-            </a:r>
-          </a:p>
-          <a:p>
-            <a:r>
-              <a:rPr lang="en-US" dirty="0" smtClean="0"/>
-              <a:t>Create a specialized LLM for generating recipes.</a:t>
-            </a:r>
-          </a:p>
-          <a:p>
-            <a:r>
-              <a:rPr lang="en-US" dirty="0" smtClean="0"/>
-              <a:t>Make it into a phone application using the cloud to handle the A.I. portion.</a:t>
-            </a:r>
+              <a:t>Missing API Operation</a:t>
+            </a:r>
+            <a:endParaRPr lang="en-US" dirty="0"/>
           </a:p>
         </p:txBody>
       </p:sp>
@@ -3886,6 +4436,180 @@
   <p:clrMapOvr>
     <a:masterClrMapping/>
   </p:clrMapOvr>
+  <p:timing>
+    <p:tnLst>
+      <p:par>
+        <p:cTn id="1" dur="indefinite" restart="never" nodeType="tmRoot">
+          <p:childTnLst>
+            <p:seq concurrent="1" nextAc="seek">
+              <p:cTn id="2" restart="whenNotActive" fill="hold" evtFilter="cancelBubble" nodeType="interactiveSeq">
+                <p:stCondLst>
+                  <p:cond evt="onClick" delay="0">
+                    <p:tgtEl>
+                      <p:spTgt spid="4"/>
+                    </p:tgtEl>
+                  </p:cond>
+                </p:stCondLst>
+                <p:endSync evt="end" delay="0">
+                  <p:rtn val="all"/>
+                </p:endSync>
+                <p:childTnLst>
+                  <p:par>
+                    <p:cTn id="3" fill="hold">
+                      <p:stCondLst>
+                        <p:cond delay="0"/>
+                      </p:stCondLst>
+                      <p:childTnLst>
+                        <p:par>
+                          <p:cTn id="4" fill="hold">
+                            <p:stCondLst>
+                              <p:cond delay="0"/>
+                            </p:stCondLst>
+                            <p:childTnLst>
+                              <p:par>
+                                <p:cTn id="5" presetID="2" presetClass="mediacall" presetSubtype="0" fill="hold" nodeType="clickEffect">
+                                  <p:stCondLst>
+                                    <p:cond delay="0"/>
+                                  </p:stCondLst>
+                                  <p:childTnLst>
+                                    <p:cmd type="call" cmd="togglePause">
+                                      <p:cBhvr>
+                                        <p:cTn id="6" dur="1" fill="hold"/>
+                                        <p:tgtEl>
+                                          <p:spTgt spid="4"/>
+                                        </p:tgtEl>
+                                      </p:cBhvr>
+                                    </p:cmd>
+                                  </p:childTnLst>
+                                </p:cTn>
+                              </p:par>
+                            </p:childTnLst>
+                          </p:cTn>
+                        </p:par>
+                      </p:childTnLst>
+                    </p:cTn>
+                  </p:par>
+                </p:childTnLst>
+              </p:cTn>
+              <p:nextCondLst>
+                <p:cond evt="onClick" delay="0">
+                  <p:tgtEl>
+                    <p:spTgt spid="4"/>
+                  </p:tgtEl>
+                </p:cond>
+              </p:nextCondLst>
+            </p:seq>
+            <p:video fullScrn="1">
+              <p:cMediaNode>
+                <p:cTn id="7" fill="hold" display="0">
+                  <p:stCondLst>
+                    <p:cond delay="indefinite"/>
+                  </p:stCondLst>
+                  <p:endCondLst>
+                    <p:cond evt="onNext" delay="0">
+                      <p:tgtEl>
+                        <p:sldTgt/>
+                      </p:tgtEl>
+                    </p:cond>
+                    <p:cond evt="onPrev" delay="0">
+                      <p:tgtEl>
+                        <p:sldTgt/>
+                      </p:tgtEl>
+                    </p:cond>
+                  </p:endCondLst>
+                </p:cTn>
+                <p:tgtEl>
+                  <p:spTgt spid="4"/>
+                </p:tgtEl>
+              </p:cMediaNode>
+            </p:video>
+            <p:seq concurrent="1" nextAc="seek">
+              <p:cTn id="8" restart="whenNotActive" fill="hold" evtFilter="cancelBubble" nodeType="interactiveSeq">
+                <p:stCondLst>
+                  <p:cond evt="onClick" delay="0">
+                    <p:tgtEl>
+                      <p:spTgt spid="5"/>
+                    </p:tgtEl>
+                  </p:cond>
+                </p:stCondLst>
+                <p:endSync evt="end" delay="0">
+                  <p:rtn val="all"/>
+                </p:endSync>
+                <p:childTnLst>
+                  <p:par>
+                    <p:cTn id="9" fill="hold">
+                      <p:stCondLst>
+                        <p:cond delay="0"/>
+                      </p:stCondLst>
+                      <p:childTnLst>
+                        <p:par>
+                          <p:cTn id="10" fill="hold">
+                            <p:stCondLst>
+                              <p:cond delay="0"/>
+                            </p:stCondLst>
+                            <p:childTnLst>
+                              <p:par>
+                                <p:cTn id="11" presetID="2" presetClass="mediacall" presetSubtype="0" fill="hold" nodeType="clickEffect">
+                                  <p:stCondLst>
+                                    <p:cond delay="0"/>
+                                  </p:stCondLst>
+                                  <p:childTnLst>
+                                    <p:cmd type="call" cmd="togglePause">
+                                      <p:cBhvr>
+                                        <p:cTn id="12" dur="1" fill="hold"/>
+                                        <p:tgtEl>
+                                          <p:spTgt spid="5"/>
+                                        </p:tgtEl>
+                                      </p:cBhvr>
+                                    </p:cmd>
+                                  </p:childTnLst>
+                                </p:cTn>
+                              </p:par>
+                            </p:childTnLst>
+                          </p:cTn>
+                        </p:par>
+                      </p:childTnLst>
+                    </p:cTn>
+                  </p:par>
+                </p:childTnLst>
+              </p:cTn>
+              <p:nextCondLst>
+                <p:cond evt="onClick" delay="0">
+                  <p:tgtEl>
+                    <p:spTgt spid="5"/>
+                  </p:tgtEl>
+                </p:cond>
+              </p:nextCondLst>
+            </p:seq>
+            <p:video fullScrn="1">
+              <p:cMediaNode>
+                <p:cTn id="13" fill="hold" display="0">
+                  <p:stCondLst>
+                    <p:cond delay="indefinite"/>
+                  </p:stCondLst>
+                  <p:endCondLst>
+                    <p:cond evt="onNext" delay="0">
+                      <p:tgtEl>
+                        <p:sldTgt/>
+                      </p:tgtEl>
+                    </p:cond>
+                    <p:cond evt="onPrev" delay="0">
+                      <p:tgtEl>
+                        <p:sldTgt/>
+                      </p:tgtEl>
+                    </p:cond>
+                  </p:endCondLst>
+                </p:cTn>
+                <p:tgtEl>
+                  <p:spTgt spid="5"/>
+                </p:tgtEl>
+              </p:cMediaNode>
+            </p:video>
+          </p:childTnLst>
+        </p:cTn>
+      </p:par>
+    </p:tnLst>
+  </p:timing>
 </p:sld>
 </file>
 
@@ -3923,7 +4647,7 @@
           <a:p>
             <a:r>
               <a:rPr lang="en-US" dirty="0" smtClean="0"/>
-              <a:t>References</a:t>
+              <a:t>Future Improvements</a:t>
             </a:r>
             <a:endParaRPr lang="en-US" dirty="0"/>
           </a:p>
@@ -3942,62 +4666,62 @@
         <p:spPr/>
         <p:txBody>
           <a:bodyPr>
-            <a:normAutofit fontScale="92500" lnSpcReduction="10000"/>
+            <a:normAutofit fontScale="70000" lnSpcReduction="20000"/>
           </a:bodyPr>
           <a:lstStyle/>
           <a:p>
             <a:r>
-              <a:rPr lang="en-US" dirty="0" smtClean="0">
-                <a:hlinkClick r:id="rId2"/>
-              </a:rPr>
-              <a:t>https://platform.ultralytics.com/</a:t>
-            </a:r>
-            <a:endParaRPr lang="en-US" dirty="0" smtClean="0"/>
-          </a:p>
-          <a:p>
-            <a:r>
-              <a:rPr lang="en-US" dirty="0" smtClean="0">
-                <a:hlinkClick r:id="rId3"/>
-              </a:rPr>
-              <a:t>https://universe.roboflow.com/food-recipe-ingredient-images-0gnku/food-ingredients-dataset</a:t>
-            </a:r>
-            <a:endParaRPr lang="en-US" dirty="0" smtClean="0"/>
-          </a:p>
-          <a:p>
-            <a:r>
-              <a:rPr lang="en-US" dirty="0" smtClean="0">
-                <a:hlinkClick r:id="rId4"/>
-              </a:rPr>
-              <a:t>https://www.themealdb.com/</a:t>
-            </a:r>
-            <a:endParaRPr lang="en-US" dirty="0" smtClean="0"/>
-          </a:p>
-          <a:p>
-            <a:r>
-              <a:rPr lang="en-US" dirty="0" smtClean="0">
-                <a:hlinkClick r:id="rId5"/>
-              </a:rPr>
-              <a:t>https://openai.com/</a:t>
-            </a:r>
-            <a:endParaRPr lang="en-US" dirty="0" smtClean="0"/>
-          </a:p>
-          <a:p>
-            <a:r>
-              <a:rPr lang="en-US" dirty="0" smtClean="0">
-                <a:hlinkClick r:id="rId6"/>
-              </a:rPr>
-              <a:t>https://www.nvidia.com/en-us/autonomous-machines/embedded-systems/jetson-thor/</a:t>
-            </a:r>
-            <a:endParaRPr lang="en-US" dirty="0" smtClean="0"/>
-          </a:p>
-          <a:p>
-            <a:r>
-              <a:rPr lang="en-US" dirty="0" smtClean="0">
-                <a:hlinkClick r:id="rId7"/>
-              </a:rPr>
-              <a:t>https://colab.research.google.com/</a:t>
-            </a:r>
-            <a:endParaRPr lang="en-US" dirty="0" smtClean="0"/>
+              <a:rPr lang="en-US" dirty="0" smtClean="0"/>
+              <a:t>Add the ability to use multiple pictures and concatenate the results.</a:t>
+            </a:r>
+          </a:p>
+          <a:p>
+            <a:r>
+              <a:rPr lang="en-US" dirty="0" smtClean="0"/>
+              <a:t>Develop a better dataset of ingredients.</a:t>
+            </a:r>
+          </a:p>
+          <a:p>
+            <a:r>
+              <a:rPr lang="en-US" dirty="0" smtClean="0"/>
+              <a:t>Improve the object detection model.</a:t>
+            </a:r>
+          </a:p>
+          <a:p>
+            <a:r>
+              <a:rPr lang="en-US" dirty="0" smtClean="0"/>
+              <a:t>Add save and print capabilities for the recipes.</a:t>
+            </a:r>
+          </a:p>
+          <a:p>
+            <a:r>
+              <a:rPr lang="en-US" dirty="0" smtClean="0"/>
+              <a:t>Add the ability to change the number of recipes to be retrieved.</a:t>
+            </a:r>
+          </a:p>
+          <a:p>
+            <a:r>
+              <a:rPr lang="en-US" dirty="0" smtClean="0"/>
+              <a:t>Add the ability to get specialized recipes based on dietary constraints and meal type.</a:t>
+            </a:r>
+          </a:p>
+          <a:p>
+            <a:r>
+              <a:rPr lang="en-US" dirty="0" smtClean="0"/>
+              <a:t>Place each recipe in a different tab of a text box.</a:t>
+            </a:r>
+          </a:p>
+          <a:p>
+            <a:r>
+              <a:rPr lang="en-US" dirty="0" smtClean="0"/>
+              <a:t>Create a specialized LLM for generating recipes.</a:t>
+            </a:r>
+          </a:p>
+          <a:p>
+            <a:r>
+              <a:rPr lang="en-US" dirty="0" smtClean="0"/>
+              <a:t>Make it into a phone application using the cloud to handle the A.I. portion.</a:t>
+            </a:r>
           </a:p>
         </p:txBody>
       </p:sp>
@@ -4006,6 +4730,13 @@
   <p:clrMapOvr>
     <a:masterClrMapping/>
   </p:clrMapOvr>
+  <p:timing>
+    <p:tnLst>
+      <p:par>
+        <p:cTn id="1" dur="indefinite" restart="never" nodeType="tmRoot"/>
+      </p:par>
+    </p:tnLst>
+  </p:timing>
 </p:sld>
 </file>
 

</xml_diff>